<commit_message>
Fit CHEF cover and appendix titles inside editable frames
</commit_message>
<xml_diff>
--- a/slides/datasets-in-10-minutes-chef.pptx
+++ b/slides/datasets-in-10-minutes-chef.pptx
@@ -7411,11 +7411,11 @@
         <p:spPr>
           <a:xfrm>
             <a:off x="548640" y="2647277"/>
-            <a:ext cx="8046720" cy="989965"/>
+            <a:ext cx="8046720" cy="1091565"/>
           </a:xfrm>
         </p:spPr>
         <p:txBody>
-          <a:bodyPr lIns="0" rIns="0" tIns="0" bIns="0">
+          <a:bodyPr lIns="0" rIns="0" tIns="0" bIns="101600">
             <a:noAutofit/>
           </a:bodyPr>
           <a:lstStyle/>
@@ -17996,11 +17996,11 @@
         <p:spPr>
           <a:xfrm>
             <a:off x="548640" y="2484835"/>
-            <a:ext cx="8046720" cy="585216"/>
+            <a:ext cx="8046720" cy="686816"/>
           </a:xfrm>
         </p:spPr>
         <p:txBody>
-          <a:bodyPr wrap="square" lIns="0" rIns="0" tIns="0" bIns="0" anchor="ctr">
+          <a:bodyPr wrap="square" lIns="0" rIns="0" tIns="0" bIns="101600" anchor="ctr">
             <a:noAutofit/>
           </a:bodyPr>
           <a:lstStyle/>

</xml_diff>